<commit_message>
Traducir nombres de tablas/columnas del ejemplo de biblioteca a inglés (authors, books, loans) en todo el repo; solo pgAdmin (sin TablePlus) en la presentación; cambiar link de normalización a DataCamp
Co-Authored-By: Claude Sonnet 5 <noreply@anthropic.com>
</commit_message>
<xml_diff>
--- a/clases/clase-1/presentacion.pptx
+++ b/clases/clase-1/presentacion.pptx
@@ -2398,7 +2398,7 @@
                 <a:ea typeface="Calibri" pitchFamily="34" charset="-122"/>
                 <a:cs typeface="Calibri" pitchFamily="34" charset="-120"/>
               </a:rPr>
-              <a:t>Recreamos en vivo el diagrama de Biblioteca a partir de lo que vieron en TablePlus.</a:t>
+              <a:t>Recreamos en vivo el diagrama de biblioteca a partir de lo que vieron en pgAdmin.</a:t>
             </a:r>
             <a:endParaRPr lang="en-US" sz="1400" dirty="0"/>
           </a:p>
@@ -4767,7 +4767,7 @@
                 <a:ea typeface="Cambria" pitchFamily="34" charset="-122"/>
                 <a:cs typeface="Cambria" pitchFamily="34" charset="-120"/>
               </a:rPr>
-              <a:t>Mini-DB "Biblioteca": autores → libros → préstamos</a:t>
+              <a:t>Mini-DB de biblioteca: authors → books → loans</a:t>
             </a:r>
             <a:endParaRPr lang="en-US" sz="2800" dirty="0"/>
           </a:p>
@@ -4831,7 +4831,7 @@
                 <a:ea typeface="Calibri" pitchFamily="34" charset="-122"/>
                 <a:cs typeface="Calibri" pitchFamily="34" charset="-120"/>
               </a:rPr>
-              <a:t>Abrimos TablePlus/pgAdmin y navegamos juntos: tablas autores, libros, prestamos.</a:t>
+              <a:t>Abrimos pgAdmin y navegamos juntos: tablas authors, books, loans.</a:t>
             </a:r>
             <a:endParaRPr lang="en-US" sz="1600" dirty="0"/>
           </a:p>
@@ -4852,7 +4852,7 @@
                 <a:ea typeface="Calibri" pitchFamily="34" charset="-122"/>
                 <a:cs typeface="Calibri" pitchFamily="34" charset="-120"/>
               </a:rPr>
-              <a:t>Señalamos en vivo: ahí está la clave primaria (id), ahí la clave foránea (autor_id).</a:t>
+              <a:t>Señalamos en vivo: ahí está la clave primaria (id), ahí la clave foránea (author_id).</a:t>
             </a:r>
             <a:endParaRPr lang="en-US" sz="1600" dirty="0"/>
           </a:p>

</xml_diff>